<commit_message>
Add ZIP support, update 색판 뒤집기 빙고 assets, add PPTX/ZIP notes in download UI
Co-Authored-By: Claude Opus 4.6 (1M context) <noreply@anthropic.com>
</commit_message>
<xml_diff>
--- a/public/downloads/games/color-flip-bingo/rules.pptx
+++ b/public/downloads/games/color-flip-bingo/rules.pptx
@@ -15,16 +15,12 @@
   <p:notesSz cx="6858000" cy="9144000"/>
   <p:embeddedFontLst>
     <p:embeddedFont>
-      <p:font typeface="Jua" charset="1" panose="00000000000000000000"/>
+      <p:font typeface="무궁화 고딕" charset="1" panose="02020603020101020101"/>
       <p:regular r:id="rId11"/>
     </p:embeddedFont>
     <p:embeddedFont>
-      <p:font typeface="TDTD갬성명조" charset="1" panose="02000503000000000000"/>
+      <p:font typeface="무궁화 고딕 Bold" charset="1" panose="02020603020101020101"/>
       <p:regular r:id="rId12"/>
-    </p:embeddedFont>
-    <p:embeddedFont>
-      <p:font typeface="TDTD가온" charset="1" panose="02000503000000000000"/>
-      <p:regular r:id="rId13"/>
     </p:embeddedFont>
   </p:embeddedFontLst>
   <p:defaultTextStyle>
@@ -3142,8 +3138,8 @@
         </p:nvSpPr>
         <p:spPr>
           <a:xfrm rot="0">
-            <a:off x="1028700" y="3892867"/>
-            <a:ext cx="15555091" cy="2200275"/>
+            <a:off x="1028700" y="4178617"/>
+            <a:ext cx="15555091" cy="1914525"/>
           </a:xfrm>
           <a:prstGeom prst="rect">
             <a:avLst/>
@@ -3165,10 +3161,10 @@
                 <a:solidFill>
                   <a:srgbClr val="FFFAEF"/>
                 </a:solidFill>
-                <a:latin typeface="Jua"/>
-                <a:ea typeface="Jua"/>
-                <a:cs typeface="Jua"/>
-                <a:sym typeface="Jua"/>
+                <a:latin typeface="무궁화 고딕"/>
+                <a:ea typeface="무궁화 고딕"/>
+                <a:cs typeface="무궁화 고딕"/>
+                <a:sym typeface="무궁화 고딕"/>
               </a:rPr>
               <a:t>색판 뒤집기 빙고</a:t>
             </a:r>
@@ -3183,8 +3179,8 @@
         </p:nvSpPr>
         <p:spPr>
           <a:xfrm rot="0">
-            <a:off x="15264803" y="9812655"/>
-            <a:ext cx="2637975" cy="474345"/>
+            <a:off x="14542909" y="9822180"/>
+            <a:ext cx="3359870" cy="464820"/>
           </a:xfrm>
           <a:prstGeom prst="rect">
             <a:avLst/>
@@ -3209,10 +3205,10 @@
                 <a:solidFill>
                   <a:srgbClr val="FFFFFF"/>
                 </a:solidFill>
-                <a:latin typeface="TDTD갬성명조"/>
-                <a:ea typeface="TDTD갬성명조"/>
-                <a:cs typeface="TDTD갬성명조"/>
-                <a:sym typeface="TDTD갬성명조"/>
+                <a:latin typeface="무궁화 고딕"/>
+                <a:ea typeface="무궁화 고딕"/>
+                <a:cs typeface="무궁화 고딕"/>
+                <a:sym typeface="무궁화 고딕"/>
               </a:rPr>
               <a:t>ⓒ 2026. Sunday Play</a:t>
             </a:r>
@@ -3361,8 +3357,8 @@
         </p:nvSpPr>
         <p:spPr>
           <a:xfrm rot="0">
-            <a:off x="11392761" y="600705"/>
-            <a:ext cx="5362043" cy="1600200"/>
+            <a:off x="11392761" y="819780"/>
+            <a:ext cx="5362043" cy="1381125"/>
           </a:xfrm>
           <a:prstGeom prst="rect">
             <a:avLst/>
@@ -3384,10 +3380,10 @@
                 <a:solidFill>
                   <a:srgbClr val="FFFAEF"/>
                 </a:solidFill>
-                <a:latin typeface="Jua"/>
-                <a:ea typeface="Jua"/>
-                <a:cs typeface="Jua"/>
-                <a:sym typeface="Jua"/>
+                <a:latin typeface="무궁화 고딕"/>
+                <a:ea typeface="무궁화 고딕"/>
+                <a:cs typeface="무궁화 고딕"/>
+                <a:sym typeface="무궁화 고딕"/>
               </a:rPr>
               <a:t>규칙</a:t>
             </a:r>
@@ -3403,9 +3399,9 @@
         <p:grpSpPr>
           <a:xfrm rot="0">
             <a:off x="246010" y="286490"/>
-            <a:ext cx="10830855" cy="2313869"/>
+            <a:ext cx="10830855" cy="2190991"/>
             <a:chOff x="0" y="0"/>
-            <a:chExt cx="14441140" cy="3085159"/>
+            <a:chExt cx="14441140" cy="2921322"/>
           </a:xfrm>
         </p:grpSpPr>
         <p:sp>
@@ -3416,8 +3412,8 @@
           </p:nvSpPr>
           <p:spPr>
             <a:xfrm rot="0">
-              <a:off x="0" y="1350128"/>
-              <a:ext cx="14441140" cy="1735032"/>
+              <a:off x="0" y="1360069"/>
+              <a:ext cx="14441140" cy="1561253"/>
             </a:xfrm>
             <a:prstGeom prst="rect">
               <a:avLst/>
@@ -3429,55 +3425,51 @@
             </a:bodyPr>
             <a:lstStyle/>
             <a:p>
-              <a:pPr algn="l" marL="820421" indent="-410210" lvl="1">
+              <a:pPr algn="l">
                 <a:lnSpc>
-                  <a:spcPts val="5320"/>
+                  <a:spcPts val="4760"/>
                 </a:lnSpc>
-                <a:buFont typeface="Arial"/>
-                <a:buChar char="•"/>
               </a:pPr>
               <a:r>
-                <a:rPr lang="en-US" sz="3800">
+                <a:rPr lang="en-US" sz="3400">
                   <a:solidFill>
                     <a:srgbClr val="FFFAEF"/>
                   </a:solidFill>
-                  <a:latin typeface="TDTD가온"/>
-                  <a:ea typeface="TDTD가온"/>
-                  <a:cs typeface="TDTD가온"/>
-                  <a:sym typeface="TDTD가온"/>
+                  <a:latin typeface="무궁화 고딕"/>
+                  <a:ea typeface="무궁화 고딕"/>
+                  <a:cs typeface="무궁화 고딕"/>
+                  <a:sym typeface="무궁화 고딕"/>
                 </a:rPr>
                 <a:t>팀을 2팀으로 나누고</a:t>
               </a:r>
               <a:r>
-                <a:rPr lang="en-US" sz="3800">
+                <a:rPr lang="en-US" sz="3400">
                   <a:solidFill>
                     <a:srgbClr val="FFFAEF"/>
                   </a:solidFill>
-                  <a:latin typeface="TDTD가온"/>
-                  <a:ea typeface="TDTD가온"/>
-                  <a:cs typeface="TDTD가온"/>
-                  <a:sym typeface="TDTD가온"/>
+                  <a:latin typeface="무궁화 고딕"/>
+                  <a:ea typeface="무궁화 고딕"/>
+                  <a:cs typeface="무궁화 고딕"/>
+                  <a:sym typeface="무궁화 고딕"/>
                 </a:rPr>
                 <a:t> 각 팀 색상을 정합니다.(빨강 vs 파랑)   </a:t>
               </a:r>
             </a:p>
             <a:p>
-              <a:pPr algn="l" marL="820421" indent="-410210" lvl="1">
+              <a:pPr algn="l">
                 <a:lnSpc>
-                  <a:spcPts val="5320"/>
+                  <a:spcPts val="4760"/>
                 </a:lnSpc>
-                <a:buFont typeface="Arial"/>
-                <a:buChar char="•"/>
               </a:pPr>
               <a:r>
-                <a:rPr lang="en-US" sz="3800">
+                <a:rPr lang="en-US" sz="3400">
                   <a:solidFill>
                     <a:srgbClr val="FFFAEF"/>
                   </a:solidFill>
-                  <a:latin typeface="TDTD가온"/>
-                  <a:ea typeface="TDTD가온"/>
-                  <a:cs typeface="TDTD가온"/>
-                  <a:sym typeface="TDTD가온"/>
+                  <a:latin typeface="무궁화 고딕"/>
+                  <a:ea typeface="무궁화 고딕"/>
+                  <a:cs typeface="무궁화 고딕"/>
+                  <a:sym typeface="무궁화 고딕"/>
                 </a:rPr>
                 <a:t>색판을 배치하고 출발선에 일렬로 줄을 섭니다!  </a:t>
               </a:r>
@@ -3492,8 +3484,8 @@
           </p:nvSpPr>
           <p:spPr>
             <a:xfrm rot="0">
-              <a:off x="0" y="-152400"/>
-              <a:ext cx="10684245" cy="1065427"/>
+              <a:off x="0" y="-47625"/>
+              <a:ext cx="10684245" cy="961068"/>
             </a:xfrm>
             <a:prstGeom prst="rect">
               <a:avLst/>
@@ -3515,10 +3507,10 @@
                   <a:solidFill>
                     <a:srgbClr val="FFFAEF"/>
                   </a:solidFill>
-                  <a:latin typeface="Jua"/>
-                  <a:ea typeface="Jua"/>
-                  <a:cs typeface="Jua"/>
-                  <a:sym typeface="Jua"/>
+                  <a:latin typeface="무궁화 고딕 Bold"/>
+                  <a:ea typeface="무궁화 고딕 Bold"/>
+                  <a:cs typeface="무궁화 고딕 Bold"/>
+                  <a:sym typeface="무궁화 고딕 Bold"/>
                 </a:rPr>
                 <a:t>STEP 1.</a:t>
               </a:r>
@@ -3534,10 +3526,10 @@
         </p:nvGrpSpPr>
         <p:grpSpPr>
           <a:xfrm rot="0">
-            <a:off x="7231210" y="7319739"/>
-            <a:ext cx="11056790" cy="2967261"/>
+            <a:off x="7667984" y="7720186"/>
+            <a:ext cx="10620016" cy="2177320"/>
             <a:chOff x="0" y="0"/>
-            <a:chExt cx="14742386" cy="3956347"/>
+            <a:chExt cx="14160021" cy="2903094"/>
           </a:xfrm>
         </p:grpSpPr>
         <p:sp>
@@ -3548,8 +3540,8 @@
           </p:nvSpPr>
           <p:spPr>
             <a:xfrm rot="0">
-              <a:off x="0" y="1332315"/>
-              <a:ext cx="14742386" cy="2624033"/>
+              <a:off x="0" y="1341840"/>
+              <a:ext cx="14160021" cy="1561254"/>
             </a:xfrm>
             <a:prstGeom prst="rect">
               <a:avLst/>
@@ -3561,65 +3553,54 @@
             </a:bodyPr>
             <a:lstStyle/>
             <a:p>
-              <a:pPr algn="l" marL="820414" indent="-410207" lvl="1">
+              <a:pPr algn="l">
                 <a:lnSpc>
-                  <a:spcPts val="5319"/>
+                  <a:spcPts val="4759"/>
                 </a:lnSpc>
-                <a:buFont typeface="Arial"/>
-                <a:buChar char="•"/>
               </a:pPr>
               <a:r>
-                <a:rPr lang="en-US" sz="3799">
+                <a:rPr lang="en-US" sz="3399">
                   <a:solidFill>
                     <a:srgbClr val="FFFAEF"/>
                   </a:solidFill>
-                  <a:latin typeface="TDTD가온"/>
-                  <a:ea typeface="TDTD가온"/>
-                  <a:cs typeface="TDTD가온"/>
-                  <a:sym typeface="TDTD가온"/>
+                  <a:latin typeface="무궁화 고딕"/>
+                  <a:ea typeface="무궁화 고딕"/>
+                  <a:cs typeface="무궁화 고딕"/>
+                  <a:sym typeface="무궁화 고딕"/>
                 </a:rPr>
                 <a:t>가로·세로·대각선</a:t>
               </a:r>
               <a:r>
-                <a:rPr lang="en-US" sz="3799">
+                <a:rPr lang="en-US" sz="3399">
                   <a:solidFill>
                     <a:srgbClr val="FFFAEF"/>
                   </a:solidFill>
-                  <a:latin typeface="TDTD가온"/>
-                  <a:ea typeface="TDTD가온"/>
-                  <a:cs typeface="TDTD가온"/>
-                  <a:sym typeface="TDTD가온"/>
+                  <a:latin typeface="무궁화 고딕"/>
+                  <a:ea typeface="무궁화 고딕"/>
+                  <a:cs typeface="무궁화 고딕"/>
+                  <a:sym typeface="무궁화 고딕"/>
                 </a:rPr>
                 <a:t> 한 줄이 자기 팀 색 → "빙고!" 라운드 승리!</a:t>
               </a:r>
             </a:p>
             <a:p>
-              <a:pPr algn="l" marL="820414" indent="-410207" lvl="1">
+              <a:pPr algn="l">
                 <a:lnSpc>
-                  <a:spcPts val="5319"/>
+                  <a:spcPts val="4759"/>
                 </a:lnSpc>
-                <a:buFont typeface="Arial"/>
-                <a:buChar char="•"/>
               </a:pPr>
               <a:r>
-                <a:rPr lang="en-US" sz="3799">
+                <a:rPr lang="en-US" sz="3399">
                   <a:solidFill>
                     <a:srgbClr val="FFFAEF"/>
                   </a:solidFill>
-                  <a:latin typeface="TDTD가온"/>
-                  <a:ea typeface="TDTD가온"/>
-                  <a:cs typeface="TDTD가온"/>
-                  <a:sym typeface="TDTD가온"/>
+                  <a:latin typeface="무궁화 고딕"/>
+                  <a:ea typeface="무궁화 고딕"/>
+                  <a:cs typeface="무궁화 고딕"/>
+                  <a:sym typeface="무궁화 고딕"/>
                 </a:rPr>
-                <a:t> 여러 라운드 반복 후 최다 승 팀이 최종 우승!</a:t>
+                <a:t>여러 라운드 반복 후 최다 승 팀이 최종 우승!</a:t>
               </a:r>
-            </a:p>
-            <a:p>
-              <a:pPr algn="l">
-                <a:lnSpc>
-                  <a:spcPts val="5319"/>
-                </a:lnSpc>
-              </a:pPr>
             </a:p>
           </p:txBody>
         </p:sp>
@@ -3631,8 +3612,8 @@
           </p:nvSpPr>
           <p:spPr>
             <a:xfrm rot="0">
-              <a:off x="0" y="-161925"/>
-              <a:ext cx="14742386" cy="1063625"/>
+              <a:off x="0" y="-47625"/>
+              <a:ext cx="14160021" cy="949325"/>
             </a:xfrm>
             <a:prstGeom prst="rect">
               <a:avLst/>
@@ -3654,10 +3635,10 @@
                   <a:solidFill>
                     <a:srgbClr val="FFFAEF"/>
                   </a:solidFill>
-                  <a:latin typeface="Jua"/>
-                  <a:ea typeface="Jua"/>
-                  <a:cs typeface="Jua"/>
-                  <a:sym typeface="Jua"/>
+                  <a:latin typeface="무궁화 고딕 Bold"/>
+                  <a:ea typeface="무궁화 고딕 Bold"/>
+                  <a:cs typeface="무궁화 고딕 Bold"/>
+                  <a:sym typeface="무궁화 고딕 Bold"/>
                 </a:rPr>
                 <a:t>STEP 3.</a:t>
               </a:r>
@@ -3673,10 +3654,10 @@
         </p:nvGrpSpPr>
         <p:grpSpPr>
           <a:xfrm rot="0">
-            <a:off x="3398318" y="3326495"/>
-            <a:ext cx="11690180" cy="3634011"/>
+            <a:off x="3618897" y="3659870"/>
+            <a:ext cx="12231602" cy="2777395"/>
             <a:chOff x="0" y="0"/>
-            <a:chExt cx="15586907" cy="4845347"/>
+            <a:chExt cx="16308802" cy="3703194"/>
           </a:xfrm>
         </p:grpSpPr>
         <p:sp>
@@ -3687,8 +3668,8 @@
           </p:nvSpPr>
           <p:spPr>
             <a:xfrm rot="0">
-              <a:off x="0" y="1332315"/>
-              <a:ext cx="15586907" cy="3513033"/>
+              <a:off x="0" y="1341840"/>
+              <a:ext cx="16308802" cy="2361354"/>
             </a:xfrm>
             <a:prstGeom prst="rect">
               <a:avLst/>
@@ -3700,65 +3681,54 @@
             </a:bodyPr>
             <a:lstStyle/>
             <a:p>
-              <a:pPr algn="l" marL="820414" indent="-410207" lvl="1">
+              <a:pPr algn="l">
                 <a:lnSpc>
-                  <a:spcPts val="5319"/>
+                  <a:spcPts val="4759"/>
                 </a:lnSpc>
-                <a:buFont typeface="Arial"/>
-                <a:buChar char="•"/>
               </a:pPr>
               <a:r>
-                <a:rPr lang="en-US" sz="3799">
+                <a:rPr lang="en-US" sz="3399">
                   <a:solidFill>
                     <a:srgbClr val="FFFAEF"/>
                   </a:solidFill>
-                  <a:latin typeface="TDTD가온"/>
-                  <a:ea typeface="TDTD가온"/>
-                  <a:cs typeface="TDTD가온"/>
-                  <a:sym typeface="TDTD가온"/>
+                  <a:latin typeface="무궁화 고딕"/>
+                  <a:ea typeface="무궁화 고딕"/>
+                  <a:cs typeface="무궁화 고딕"/>
+                  <a:sym typeface="무궁화 고딕"/>
                 </a:rPr>
                 <a:t>"</a:t>
               </a:r>
               <a:r>
-                <a:rPr lang="en-US" sz="3799">
+                <a:rPr lang="en-US" sz="3399">
                   <a:solidFill>
                     <a:srgbClr val="FFFAEF"/>
                   </a:solidFill>
-                  <a:latin typeface="TDTD가온"/>
-                  <a:ea typeface="TDTD가온"/>
-                  <a:cs typeface="TDTD가온"/>
-                  <a:sym typeface="TDTD가온"/>
+                  <a:latin typeface="무궁화 고딕"/>
+                  <a:ea typeface="무궁화 고딕"/>
+                  <a:cs typeface="무궁화 고딕"/>
+                  <a:sym typeface="무궁화 고딕"/>
                 </a:rPr>
                 <a:t>시작" 신호에 양팀 첫 주자가 동시에 출발합니다.                                             </a:t>
               </a:r>
             </a:p>
             <a:p>
-              <a:pPr algn="l" marL="820414" indent="-410207" lvl="1">
+              <a:pPr algn="l">
                 <a:lnSpc>
-                  <a:spcPts val="5319"/>
+                  <a:spcPts val="4759"/>
                 </a:lnSpc>
-                <a:buFont typeface="Arial"/>
-                <a:buChar char="•"/>
               </a:pPr>
               <a:r>
-                <a:rPr lang="en-US" sz="3799">
+                <a:rPr lang="en-US" sz="3399">
                   <a:solidFill>
                     <a:srgbClr val="FFFAEF"/>
                   </a:solidFill>
-                  <a:latin typeface="TDTD가온"/>
-                  <a:ea typeface="TDTD가온"/>
-                  <a:cs typeface="TDTD가온"/>
-                  <a:sym typeface="TDTD가온"/>
+                  <a:latin typeface="무궁화 고딕"/>
+                  <a:ea typeface="무궁화 고딕"/>
+                  <a:cs typeface="무궁화 고딕"/>
+                  <a:sym typeface="무궁화 고딕"/>
                 </a:rPr>
                 <a:t>색판 1장을 자기 팀 색으로 뒤집고, 돌아와 하이파이브로 교대합니다. 상대 팀의 색판도 뒤집을 수 있습니다!    </a:t>
               </a:r>
-            </a:p>
-            <a:p>
-              <a:pPr algn="l">
-                <a:lnSpc>
-                  <a:spcPts val="5319"/>
-                </a:lnSpc>
-              </a:pPr>
             </a:p>
           </p:txBody>
         </p:sp>
@@ -3770,8 +3740,8 @@
           </p:nvSpPr>
           <p:spPr>
             <a:xfrm rot="0">
-              <a:off x="0" y="-161925"/>
-              <a:ext cx="10551700" cy="1063625"/>
+              <a:off x="0" y="-47625"/>
+              <a:ext cx="11040394" cy="949325"/>
             </a:xfrm>
             <a:prstGeom prst="rect">
               <a:avLst/>
@@ -3793,10 +3763,10 @@
                   <a:solidFill>
                     <a:srgbClr val="FFFAEF"/>
                   </a:solidFill>
-                  <a:latin typeface="Jua"/>
-                  <a:ea typeface="Jua"/>
-                  <a:cs typeface="Jua"/>
-                  <a:sym typeface="Jua"/>
+                  <a:latin typeface="무궁화 고딕 Bold"/>
+                  <a:ea typeface="무궁화 고딕 Bold"/>
+                  <a:cs typeface="무궁화 고딕 Bold"/>
+                  <a:sym typeface="무궁화 고딕 Bold"/>
                 </a:rPr>
                 <a:t>STEP 2.</a:t>
               </a:r>
@@ -3844,8 +3814,8 @@
         </p:nvSpPr>
         <p:spPr>
           <a:xfrm rot="0">
-            <a:off x="3238925" y="4092795"/>
-            <a:ext cx="11810151" cy="2200275"/>
+            <a:off x="3238925" y="4378545"/>
+            <a:ext cx="11810151" cy="1914525"/>
           </a:xfrm>
           <a:prstGeom prst="rect">
             <a:avLst/>
@@ -3867,10 +3837,10 @@
                 <a:solidFill>
                   <a:srgbClr val="000000"/>
                 </a:solidFill>
-                <a:latin typeface="Jua"/>
-                <a:ea typeface="Jua"/>
-                <a:cs typeface="Jua"/>
-                <a:sym typeface="Jua"/>
+                <a:latin typeface="무궁화 고딕"/>
+                <a:ea typeface="무궁화 고딕"/>
+                <a:cs typeface="무궁화 고딕"/>
+                <a:sym typeface="무궁화 고딕"/>
               </a:rPr>
               <a:t>팀을 나눠주세요!</a:t>
             </a:r>
@@ -4017,8 +3987,8 @@
         </p:nvSpPr>
         <p:spPr>
           <a:xfrm rot="0">
-            <a:off x="1028700" y="3892867"/>
-            <a:ext cx="15555091" cy="2200275"/>
+            <a:off x="1028700" y="4178617"/>
+            <a:ext cx="15555091" cy="1914525"/>
           </a:xfrm>
           <a:prstGeom prst="rect">
             <a:avLst/>
@@ -4040,10 +4010,10 @@
                 <a:solidFill>
                   <a:srgbClr val="FFFAEF"/>
                 </a:solidFill>
-                <a:latin typeface="Jua"/>
-                <a:ea typeface="Jua"/>
-                <a:cs typeface="Jua"/>
-                <a:sym typeface="Jua"/>
+                <a:latin typeface="무궁화 고딕"/>
+                <a:ea typeface="무궁화 고딕"/>
+                <a:cs typeface="무궁화 고딕"/>
+                <a:sym typeface="무궁화 고딕"/>
               </a:rPr>
               <a:t>색판 뒤집기 빙고</a:t>
             </a:r>
@@ -4058,8 +4028,8 @@
         </p:nvSpPr>
         <p:spPr>
           <a:xfrm rot="0">
-            <a:off x="15264803" y="9812655"/>
-            <a:ext cx="2637975" cy="474345"/>
+            <a:off x="14542909" y="9822180"/>
+            <a:ext cx="3359870" cy="464820"/>
           </a:xfrm>
           <a:prstGeom prst="rect">
             <a:avLst/>
@@ -4084,10 +4054,10 @@
                 <a:solidFill>
                   <a:srgbClr val="FFFFFF"/>
                 </a:solidFill>
-                <a:latin typeface="TDTD갬성명조"/>
-                <a:ea typeface="TDTD갬성명조"/>
-                <a:cs typeface="TDTD갬성명조"/>
-                <a:sym typeface="TDTD갬성명조"/>
+                <a:latin typeface="무궁화 고딕"/>
+                <a:ea typeface="무궁화 고딕"/>
+                <a:cs typeface="무궁화 고딕"/>
+                <a:sym typeface="무궁화 고딕"/>
               </a:rPr>
               <a:t>ⓒ 2026. Sunday Play</a:t>
             </a:r>
@@ -4159,8 +4129,8 @@
         </p:nvSpPr>
         <p:spPr>
           <a:xfrm rot="0">
-            <a:off x="4421807" y="3895725"/>
-            <a:ext cx="9444385" cy="2200275"/>
+            <a:off x="4421807" y="4181475"/>
+            <a:ext cx="9444385" cy="1914525"/>
           </a:xfrm>
           <a:prstGeom prst="rect">
             <a:avLst/>
@@ -4182,10 +4152,10 @@
                 <a:solidFill>
                   <a:srgbClr val="000000"/>
                 </a:solidFill>
-                <a:latin typeface="Jua"/>
-                <a:ea typeface="Jua"/>
-                <a:cs typeface="Jua"/>
-                <a:sym typeface="Jua"/>
+                <a:latin typeface="무궁화 고딕"/>
+                <a:ea typeface="무궁화 고딕"/>
+                <a:cs typeface="무궁화 고딕"/>
+                <a:sym typeface="무궁화 고딕"/>
               </a:rPr>
               <a:t>감사합니다!</a:t>
             </a:r>

</xml_diff>